<commit_message>
DEDSEC TRINETRA: phosphor ops UI redesign, landing radar, dash free copy, Phase II ready
</commit_message>
<xml_diff>
--- a/presentation/TRINETRA_ET_Hackathon_2026.pptx
+++ b/presentation/TRINETRA_ET_Hackathon_2026.pptx
@@ -1717,7 +1717,7 @@
         </p:nvSpPr>
         <p:spPr>
           <a:xfrm>
-            <a:off x="548640" y="1005840"/>
+            <a:off x="548640" y="914400"/>
             <a:ext cx="7772400" cy="320040"/>
           </a:xfrm>
           <a:prstGeom prst="rect">
@@ -1742,7 +1742,7 @@
                 <a:ea typeface="Calibri" pitchFamily="34" charset="-122"/>
                 <a:cs typeface="Calibri" pitchFamily="34" charset="-120"/>
               </a:rPr>
-              <a:t>ET CRP AI HACKATHON 2026  ·  PROBLEM STATEMENT 6</a:t>
+              <a:t>TEAM DEDSEC  ·  ET CRP AI HACKATHON 2026  ·  PROBLEM STATEMENT 6</a:t>
             </a:r>
             <a:endParaRPr lang="en-US" sz="1200" dirty="0"/>
           </a:p>
@@ -1756,7 +1756,7 @@
         </p:nvSpPr>
         <p:spPr>
           <a:xfrm>
-            <a:off x="548640" y="1463040"/>
+            <a:off x="548640" y="1371600"/>
             <a:ext cx="8229600" cy="777240"/>
           </a:xfrm>
           <a:prstGeom prst="rect">
@@ -1795,8 +1795,8 @@
         </p:nvSpPr>
         <p:spPr>
           <a:xfrm>
-            <a:off x="548640" y="2240280"/>
-            <a:ext cx="8229600" cy="411480"/>
+            <a:off x="548640" y="2148840"/>
+            <a:ext cx="8229600" cy="365760"/>
           </a:xfrm>
           <a:prstGeom prst="rect">
             <a:avLst/>
@@ -1834,7 +1834,7 @@
         </p:nvSpPr>
         <p:spPr>
           <a:xfrm>
-            <a:off x="548640" y="2880360"/>
+            <a:off x="548640" y="2697480"/>
             <a:ext cx="7772400" cy="640080"/>
           </a:xfrm>
           <a:prstGeom prst="rect">
@@ -1890,7 +1890,7 @@
         </p:nvSpPr>
         <p:spPr>
           <a:xfrm>
-            <a:off x="548640" y="3931920"/>
+            <a:off x="548640" y="3520440"/>
             <a:ext cx="7772400" cy="320040"/>
           </a:xfrm>
           <a:prstGeom prst="rect">
@@ -1929,6 +1929,45 @@
         </p:nvSpPr>
         <p:spPr>
           <a:xfrm>
+            <a:off x="548640" y="4023360"/>
+            <a:ext cx="7772400" cy="320040"/>
+          </a:xfrm>
+          <a:prstGeom prst="rect">
+            <a:avLst/>
+          </a:prstGeom>
+          <a:noFill/>
+          <a:ln/>
+        </p:spPr>
+        <p:txBody>
+          <a:bodyPr wrap="square" rtlCol="0" anchor="ctr"/>
+          <a:lstStyle/>
+          <a:p>
+            <a:pPr indent="0" marL="0">
+              <a:buNone/>
+            </a:pPr>
+            <a:r>
+              <a:rPr lang="en-US" sz="1600" b="1" dirty="0">
+                <a:solidFill>
+                  <a:srgbClr val="FFFFFF"/>
+                </a:solidFill>
+                <a:latin typeface="Arial" pitchFamily="34" charset="0"/>
+                <a:ea typeface="Arial" pitchFamily="34" charset="-122"/>
+                <a:cs typeface="Arial" pitchFamily="34" charset="-120"/>
+              </a:rPr>
+              <a:t>Presented by Team DEDSEC</a:t>
+            </a:r>
+            <a:endParaRPr lang="en-US" sz="1600" dirty="0"/>
+          </a:p>
+        </p:txBody>
+      </p:sp>
+      <p:sp>
+        <p:nvSpPr>
+          <p:cNvPr id="10" name="Text 8"/>
+          <p:cNvSpPr/>
+          <p:nvPr/>
+        </p:nvSpPr>
+        <p:spPr>
+          <a:xfrm>
             <a:off x="457200" y="4828032"/>
             <a:ext cx="6858000" cy="228600"/>
           </a:xfrm>
@@ -1954,7 +1993,7 @@
                 <a:ea typeface="Calibri" pitchFamily="34" charset="-122"/>
                 <a:cs typeface="Calibri" pitchFamily="34" charset="-120"/>
               </a:rPr>
-              <a:t>TRINETRA  ·  ET AI Hackathon 2026  ·  PS-6</a:t>
+              <a:t>DEDSEC  ·  TRINETRA  ·  ET AI Hackathon 2026  ·  PS-6</a:t>
             </a:r>
             <a:endParaRPr lang="en-US" sz="1000" dirty="0"/>
           </a:p>
@@ -1962,7 +2001,7 @@
       </p:sp>
       <p:sp>
         <p:nvSpPr>
-          <p:cNvPr id="10" name="Text 8"/>
+          <p:cNvPr id="11" name="Text 9"/>
           <p:cNvSpPr/>
           <p:nvPr/>
         </p:nvSpPr>
@@ -2209,7 +2248,7 @@
                 <a:ea typeface="Calibri" pitchFamily="34" charset="-122"/>
                 <a:cs typeface="Calibri" pitchFamily="34" charset="-120"/>
               </a:rPr>
-              <a:t>TRINETRA  ·  ET AI Hackathon 2026  ·  Problem Statement 6</a:t>
+              <a:t>Team DEDSEC  ·  TRINETRA  ·  ET AI Hackathon 2026  ·  PS-6</a:t>
             </a:r>
             <a:endParaRPr lang="en-US" sz="1400" dirty="0"/>
           </a:p>
@@ -2248,7 +2287,7 @@
                 <a:ea typeface="Arial" pitchFamily="34" charset="-122"/>
                 <a:cs typeface="Arial" pitchFamily="34" charset="-120"/>
               </a:rPr>
-              <a:t>Thank you</a:t>
+              <a:t>Thank you — Team DEDSEC</a:t>
             </a:r>
             <a:endParaRPr lang="en-US" sz="1800" dirty="0"/>
           </a:p>
@@ -2287,7 +2326,7 @@
                 <a:ea typeface="Calibri" pitchFamily="34" charset="-122"/>
                 <a:cs typeface="Calibri" pitchFamily="34" charset="-120"/>
               </a:rPr>
-              <a:t>TRINETRA  ·  ET AI Hackathon 2026  ·  PS-6</a:t>
+              <a:t>DEDSEC  ·  TRINETRA  ·  ET AI Hackathon 2026  ·  PS-6</a:t>
             </a:r>
             <a:endParaRPr lang="en-US" sz="1000" dirty="0"/>
           </a:p>
@@ -2939,7 +2978,7 @@
                 <a:ea typeface="Calibri" pitchFamily="34" charset="-122"/>
                 <a:cs typeface="Calibri" pitchFamily="34" charset="-120"/>
               </a:rPr>
-              <a:t>TRINETRA  ·  ET AI Hackathon 2026  ·  PS-6</a:t>
+              <a:t>DEDSEC  ·  TRINETRA  ·  ET AI Hackathon 2026  ·  PS-6</a:t>
             </a:r>
             <a:endParaRPr lang="en-US" sz="1000" dirty="0"/>
           </a:p>
@@ -3899,7 +3938,7 @@
                 <a:ea typeface="Calibri" pitchFamily="34" charset="-122"/>
                 <a:cs typeface="Calibri" pitchFamily="34" charset="-120"/>
               </a:rPr>
-              <a:t>TRINETRA  ·  ET AI Hackathon 2026  ·  PS-6</a:t>
+              <a:t>DEDSEC  ·  TRINETRA  ·  ET AI Hackathon 2026  ·  PS-6</a:t>
             </a:r>
             <a:endParaRPr lang="en-US" sz="1000" dirty="0"/>
           </a:p>
@@ -4744,7 +4783,7 @@
                 <a:ea typeface="Calibri" pitchFamily="34" charset="-122"/>
                 <a:cs typeface="Calibri" pitchFamily="34" charset="-120"/>
               </a:rPr>
-              <a:t>TRINETRA  ·  ET AI Hackathon 2026  ·  PS-6</a:t>
+              <a:t>DEDSEC  ·  TRINETRA  ·  ET AI Hackathon 2026  ·  PS-6</a:t>
             </a:r>
             <a:endParaRPr lang="en-US" sz="1000" dirty="0"/>
           </a:p>
@@ -5501,7 +5540,7 @@
                 <a:ea typeface="Calibri" pitchFamily="34" charset="-122"/>
                 <a:cs typeface="Calibri" pitchFamily="34" charset="-120"/>
               </a:rPr>
-              <a:t>TRINETRA  ·  ET AI Hackathon 2026  ·  PS-6</a:t>
+              <a:t>DEDSEC  ·  TRINETRA  ·  ET AI Hackathon 2026  ·  PS-6</a:t>
             </a:r>
             <a:endParaRPr lang="en-US" sz="1000" dirty="0"/>
           </a:p>
@@ -6102,7 +6141,7 @@
                 <a:ea typeface="Calibri" pitchFamily="34" charset="-122"/>
                 <a:cs typeface="Calibri" pitchFamily="34" charset="-120"/>
               </a:rPr>
-              <a:t>TRINETRA  ·  ET AI Hackathon 2026  ·  PS-6</a:t>
+              <a:t>DEDSEC  ·  TRINETRA  ·  ET AI Hackathon 2026  ·  PS-6</a:t>
             </a:r>
             <a:endParaRPr lang="en-US" sz="1000" dirty="0"/>
           </a:p>
@@ -6803,7 +6842,7 @@
                 <a:ea typeface="Calibri" pitchFamily="34" charset="-122"/>
                 <a:cs typeface="Calibri" pitchFamily="34" charset="-120"/>
               </a:rPr>
-              <a:t>TRINETRA  ·  ET AI Hackathon 2026  ·  PS-6</a:t>
+              <a:t>DEDSEC  ·  TRINETRA  ·  ET AI Hackathon 2026  ·  PS-6</a:t>
             </a:r>
             <a:endParaRPr lang="en-US" sz="1000" dirty="0"/>
           </a:p>
@@ -7604,7 +7643,7 @@
                 <a:ea typeface="Calibri" pitchFamily="34" charset="-122"/>
                 <a:cs typeface="Calibri" pitchFamily="34" charset="-120"/>
               </a:rPr>
-              <a:t>TRINETRA  ·  ET AI Hackathon 2026  ·  PS-6</a:t>
+              <a:t>DEDSEC  ·  TRINETRA  ·  ET AI Hackathon 2026  ·  PS-6</a:t>
             </a:r>
             <a:endParaRPr lang="en-US" sz="1000" dirty="0"/>
           </a:p>
@@ -8399,7 +8438,7 @@
                 <a:ea typeface="Calibri" pitchFamily="34" charset="-122"/>
                 <a:cs typeface="Calibri" pitchFamily="34" charset="-120"/>
               </a:rPr>
-              <a:t>TRINETRA  ·  ET AI Hackathon 2026  ·  PS-6</a:t>
+              <a:t>DEDSEC  ·  TRINETRA  ·  ET AI Hackathon 2026  ·  PS-6</a:t>
             </a:r>
             <a:endParaRPr lang="en-US" sz="1000" dirty="0"/>
           </a:p>

</xml_diff>